<commit_message>
modelling problem slides update for 2026
</commit_message>
<xml_diff>
--- a/slides/Lecture_07_ModellingProblem.pptx
+++ b/slides/Lecture_07_ModellingProblem.pptx
@@ -286,7 +286,7 @@
             <a:fld id="{05CC55C5-3AE8-4299-988D-DFB8217A9B4E}" type="datetimeFigureOut">
               <a:rPr lang="en-GB" smtClean="0"/>
               <a:pPr/>
-              <a:t>31/08/2024</a:t>
+              <a:t>26/08/2026</a:t>
             </a:fld>
             <a:endParaRPr lang="en-GB" dirty="0"/>
           </a:p>
@@ -642,7 +642,7 @@
           <a:p>
             <a:fld id="{05CC55C5-3AE8-4299-988D-DFB8217A9B4E}" type="datetimeFigureOut">
               <a:rPr lang="en-GB" smtClean="0"/>
-              <a:t>31/08/2024</a:t>
+              <a:t>26/08/2026</a:t>
             </a:fld>
             <a:endParaRPr lang="en-GB"/>
           </a:p>
@@ -2355,7 +2355,7 @@
           <a:p>
             <a:r>
               <a:rPr lang="en-US" dirty="0"/>
-              <a:t>In this course, we have 3 sessions (today and Thursday) to enable you to think constructively about the type of model you might need for a research problem that we provide you with. </a:t>
+              <a:t>In this course, we have 3 sessions (today and Friday) to enable you to think constructively about the type of model you might need for a research problem that we provide you with. </a:t>
             </a:r>
           </a:p>
           <a:p>
@@ -2495,15 +2495,7 @@
             </a:pPr>
             <a:r>
               <a:rPr lang="en-GB" dirty="0"/>
-              <a:t>Identify which group you are in and which modelling problem you should tackle (table on </a:t>
-            </a:r>
-            <a:r>
-              <a:rPr lang="en-GB"/>
-              <a:t>course website</a:t>
-            </a:r>
-            <a:r>
-              <a:rPr lang="en-GB" dirty="0"/>
-              <a:t>)</a:t>
+              <a:t>Identify which group you are in and which modelling problem you should tackle (table on course website)</a:t>
             </a:r>
           </a:p>
           <a:p>
@@ -2551,7 +2543,7 @@
             </a:r>
             <a:r>
               <a:rPr lang="en-GB" i="1" dirty="0"/>
-              <a:t>Thursday</a:t>
+              <a:t>Friday</a:t>
             </a:r>
             <a:r>
               <a:rPr lang="en-GB" dirty="0"/>

</xml_diff>